<commit_message>
feat: add notes slide generation, connector shapes, and refined text element APIs**
</commit_message>
<xml_diff>
--- a/smoke_samples/19_editor_base.pptx
+++ b/smoke_samples/19_editor_base.pptx
@@ -203,11 +203,6 @@
 <file path=ppt/slides/slide1.xml><?xml version="1.0" encoding="utf-8"?>
 <p:sld xmlns:a="http://schemas.openxmlformats.org/drawingml/2006/main" xmlns:c="http://schemas.openxmlformats.org/drawingml/2006/chart" xmlns:r="http://schemas.openxmlformats.org/officeDocument/2006/relationships" xmlns:p="http://schemas.openxmlformats.org/presentationml/2006/main">
   <p:cSld>
-    <p:bg>
-      <p:bgRef idx="1001">
-        <a:schemeClr val="bg1"/>
-      </p:bgRef>
-    </p:bg>
     <p:spTree>
       <p:nvGrpSpPr>
         <p:cNvPr id="1" name=""/>
@@ -291,11 +286,6 @@
 <file path=ppt/slides/slide2.xml><?xml version="1.0" encoding="utf-8"?>
 <p:sld xmlns:a="http://schemas.openxmlformats.org/drawingml/2006/main" xmlns:c="http://schemas.openxmlformats.org/drawingml/2006/chart" xmlns:r="http://schemas.openxmlformats.org/officeDocument/2006/relationships" xmlns:p="http://schemas.openxmlformats.org/presentationml/2006/main">
   <p:cSld>
-    <p:bg>
-      <p:bgRef idx="1001">
-        <a:schemeClr val="bg1"/>
-      </p:bgRef>
-    </p:bg>
     <p:spTree>
       <p:nvGrpSpPr>
         <p:cNvPr id="1" name=""/>
@@ -379,11 +369,6 @@
 <file path=ppt/slides/slide3.xml><?xml version="1.0" encoding="utf-8"?>
 <p:sld xmlns:a="http://schemas.openxmlformats.org/drawingml/2006/main" xmlns:c="http://schemas.openxmlformats.org/drawingml/2006/chart" xmlns:r="http://schemas.openxmlformats.org/officeDocument/2006/relationships" xmlns:p="http://schemas.openxmlformats.org/presentationml/2006/main">
   <p:cSld>
-    <p:bg>
-      <p:bgRef idx="1001">
-        <a:schemeClr val="bg1"/>
-      </p:bgRef>
-    </p:bg>
     <p:spTree>
       <p:nvGrpSpPr>
         <p:cNvPr id="1" name=""/>
@@ -465,9 +450,9 @@
 </file>
 
 <file path=ppt/theme/theme1.xml><?xml version="1.0" encoding="utf-8"?>
-<a:theme xmlns:a="http://schemas.openxmlformats.org/drawingml/2006/main" name="Office Theme">
+<a:theme xmlns:a="http://schemas.openxmlformats.org/drawingml/2006/main" name="Office Theme marketing">
   <a:themeElements>
-    <a:clrScheme name="Office">
+    <a:clrScheme name="Office colors">
       <a:dk1>
         <a:sysClr val="windowText" lastClr="000000"/>
       </a:dk1>
@@ -505,7 +490,7 @@
         <a:srgbClr val="800080"/>
       </a:folHlink>
     </a:clrScheme>
-    <a:fontScheme name="Office">
+    <a:fontScheme name="Office fonts">
       <a:majorFont>
         <a:latin typeface="Calibri"/>
         <a:ea typeface=""/>

</xml_diff>